<commit_message>
Match ctrTitle to title, and let a level carry the highlight
Co-Authored-By: Claude Opus 5 <noreply@anthropic.com>
Signed-off-by: RyujiYasukochi <ryuji.yasu@gmail.com>
</commit_message>
<xml_diff>
--- a/tests/fixtures/phanyidx_test.pptx
+++ b/tests/fixtures/phanyidx_test.pptx
@@ -45,7 +45,7 @@
           <p:cNvPr id="3" name="body"/>
           <p:cNvSpPr/>
           <p:nvPr>
-            <p:ph idx="1" type="body"/>
+            <p:ph type="title"/>
           </p:nvPr>
         </p:nvSpPr>
         <p:spPr/>
@@ -54,6 +54,12 @@
           <a:lstStyle>
             <a:lvl1pPr>
               <a:defRPr sz="2400">
+                <a:solidFill>
+                  <a:srgbClr val="112233"/>
+                </a:solidFill>
+                <a:highlight>
+                  <a:srgbClr val="FFFF00"/>
+                </a:highlight>
                 <a:latin typeface="Arial"/>
               </a:defRPr>
             </a:lvl1pPr>
@@ -94,7 +100,7 @@
           <p:cNvPr id="2" name="ph"/>
           <p:cNvSpPr/>
           <p:nvPr>
-            <p:ph idx="4294967295" type="body"/>
+            <p:ph idx="4294967295" type="ctrTitle"/>
           </p:nvPr>
         </p:nvSpPr>
         <p:spPr>

</xml_diff>